<commit_message>
mask highly mutated sites in ha builds
</commit_message>
<xml_diff>
--- a/figure-panels/Figure5/Fig5_wstructures.pptx
+++ b/figure-panels/Figure5/Fig5_wstructures.pptx
@@ -2,12 +2,12 @@
 <file path=ppt/presentation.xml><?xml version="1.0" encoding="utf-8"?>
 <p:presentation xmlns:a="http://schemas.openxmlformats.org/drawingml/2006/main" xmlns:r="http://schemas.openxmlformats.org/officeDocument/2006/relationships" xmlns:p="http://schemas.openxmlformats.org/presentationml/2006/main" saveSubsetFonts="1" autoCompressPictures="0">
   <p:sldMasterIdLst>
-    <p:sldMasterId id="2147483756" r:id="rId1"/>
+    <p:sldMasterId id="2147483804" r:id="rId1"/>
   </p:sldMasterIdLst>
   <p:sldIdLst>
     <p:sldId id="256" r:id="rId2"/>
   </p:sldIdLst>
-  <p:sldSz cx="6950075" cy="9144000"/>
+  <p:sldSz cx="6765925" cy="8915400"/>
   <p:notesSz cx="6858000" cy="9144000"/>
   <p:defaultTextStyle>
     <a:defPPr>
@@ -141,15 +141,15 @@
         </p:nvSpPr>
         <p:spPr>
           <a:xfrm>
-            <a:off x="521256" y="1496484"/>
-            <a:ext cx="5907564" cy="3183467"/>
+            <a:off x="507445" y="1459072"/>
+            <a:ext cx="5751036" cy="3103880"/>
           </a:xfrm>
         </p:spPr>
         <p:txBody>
           <a:bodyPr anchor="b"/>
           <a:lstStyle>
             <a:lvl1pPr algn="ctr">
-              <a:defRPr sz="4561"/>
+              <a:defRPr sz="4439"/>
             </a:lvl1pPr>
           </a:lstStyle>
           <a:p>
@@ -173,8 +173,8 @@
         </p:nvSpPr>
         <p:spPr>
           <a:xfrm>
-            <a:off x="868760" y="4802717"/>
-            <a:ext cx="5212556" cy="2207683"/>
+            <a:off x="845741" y="4682649"/>
+            <a:ext cx="5074444" cy="2152491"/>
           </a:xfrm>
         </p:spPr>
         <p:txBody>
@@ -182,39 +182,39 @@
           <a:lstStyle>
             <a:lvl1pPr marL="0" indent="0" algn="ctr">
               <a:buNone/>
-              <a:defRPr sz="1824"/>
+              <a:defRPr sz="1776"/>
             </a:lvl1pPr>
-            <a:lvl2pPr marL="347518" indent="0" algn="ctr">
-              <a:buNone/>
-              <a:defRPr sz="1520"/>
+            <a:lvl2pPr marL="338282" indent="0" algn="ctr">
+              <a:buNone/>
+              <a:defRPr sz="1480"/>
             </a:lvl2pPr>
-            <a:lvl3pPr marL="695035" indent="0" algn="ctr">
-              <a:buNone/>
-              <a:defRPr sz="1368"/>
+            <a:lvl3pPr marL="676565" indent="0" algn="ctr">
+              <a:buNone/>
+              <a:defRPr sz="1332"/>
             </a:lvl3pPr>
-            <a:lvl4pPr marL="1042553" indent="0" algn="ctr">
-              <a:buNone/>
-              <a:defRPr sz="1216"/>
+            <a:lvl4pPr marL="1014847" indent="0" algn="ctr">
+              <a:buNone/>
+              <a:defRPr sz="1184"/>
             </a:lvl4pPr>
-            <a:lvl5pPr marL="1390071" indent="0" algn="ctr">
-              <a:buNone/>
-              <a:defRPr sz="1216"/>
+            <a:lvl5pPr marL="1353129" indent="0" algn="ctr">
+              <a:buNone/>
+              <a:defRPr sz="1184"/>
             </a:lvl5pPr>
-            <a:lvl6pPr marL="1737589" indent="0" algn="ctr">
-              <a:buNone/>
-              <a:defRPr sz="1216"/>
+            <a:lvl6pPr marL="1691411" indent="0" algn="ctr">
+              <a:buNone/>
+              <a:defRPr sz="1184"/>
             </a:lvl6pPr>
-            <a:lvl7pPr marL="2085106" indent="0" algn="ctr">
-              <a:buNone/>
-              <a:defRPr sz="1216"/>
+            <a:lvl7pPr marL="2029694" indent="0" algn="ctr">
+              <a:buNone/>
+              <a:defRPr sz="1184"/>
             </a:lvl7pPr>
-            <a:lvl8pPr marL="2432624" indent="0" algn="ctr">
-              <a:buNone/>
-              <a:defRPr sz="1216"/>
+            <a:lvl8pPr marL="2367976" indent="0" algn="ctr">
+              <a:buNone/>
+              <a:defRPr sz="1184"/>
             </a:lvl8pPr>
-            <a:lvl9pPr marL="2780142" indent="0" algn="ctr">
-              <a:buNone/>
-              <a:defRPr sz="1216"/>
+            <a:lvl9pPr marL="2706258" indent="0" algn="ctr">
+              <a:buNone/>
+              <a:defRPr sz="1184"/>
             </a:lvl9pPr>
           </a:lstStyle>
           <a:p>
@@ -243,7 +243,7 @@
           <a:p>
             <a:fld id="{A251CCDE-328B-3447-911A-D9F0DCC9D8CE}" type="datetimeFigureOut">
               <a:rPr lang="en-US" smtClean="0"/>
-              <a:t>4/11/25</a:t>
+              <a:t>4/23/25</a:t>
             </a:fld>
             <a:endParaRPr lang="en-US"/>
           </a:p>
@@ -294,7 +294,7 @@
     </p:spTree>
     <p:extLst>
       <p:ext uri="{BB962C8B-B14F-4D97-AF65-F5344CB8AC3E}">
-        <p14:creationId xmlns:p14="http://schemas.microsoft.com/office/powerpoint/2010/main" val="3481789255"/>
+        <p14:creationId xmlns:p14="http://schemas.microsoft.com/office/powerpoint/2010/main" val="2149403597"/>
       </p:ext>
     </p:extLst>
   </p:cSld>
@@ -413,7 +413,7 @@
           <a:p>
             <a:fld id="{A251CCDE-328B-3447-911A-D9F0DCC9D8CE}" type="datetimeFigureOut">
               <a:rPr lang="en-US" smtClean="0"/>
-              <a:t>4/11/25</a:t>
+              <a:t>4/23/25</a:t>
             </a:fld>
             <a:endParaRPr lang="en-US"/>
           </a:p>
@@ -464,7 +464,7 @@
     </p:spTree>
     <p:extLst>
       <p:ext uri="{BB962C8B-B14F-4D97-AF65-F5344CB8AC3E}">
-        <p14:creationId xmlns:p14="http://schemas.microsoft.com/office/powerpoint/2010/main" val="4269406600"/>
+        <p14:creationId xmlns:p14="http://schemas.microsoft.com/office/powerpoint/2010/main" val="2691165900"/>
       </p:ext>
     </p:extLst>
   </p:cSld>
@@ -503,8 +503,8 @@
         </p:nvSpPr>
         <p:spPr>
           <a:xfrm>
-            <a:off x="4973648" y="486833"/>
-            <a:ext cx="1498610" cy="7749117"/>
+            <a:off x="4841865" y="474663"/>
+            <a:ext cx="1458903" cy="7555389"/>
           </a:xfrm>
         </p:spPr>
         <p:txBody>
@@ -531,8 +531,8 @@
         </p:nvSpPr>
         <p:spPr>
           <a:xfrm>
-            <a:off x="477818" y="486833"/>
-            <a:ext cx="4408954" cy="7749117"/>
+            <a:off x="465158" y="474663"/>
+            <a:ext cx="4292134" cy="7555389"/>
           </a:xfrm>
         </p:spPr>
         <p:txBody>
@@ -593,7 +593,7 @@
           <a:p>
             <a:fld id="{A251CCDE-328B-3447-911A-D9F0DCC9D8CE}" type="datetimeFigureOut">
               <a:rPr lang="en-US" smtClean="0"/>
-              <a:t>4/11/25</a:t>
+              <a:t>4/23/25</a:t>
             </a:fld>
             <a:endParaRPr lang="en-US"/>
           </a:p>
@@ -644,7 +644,7 @@
     </p:spTree>
     <p:extLst>
       <p:ext uri="{BB962C8B-B14F-4D97-AF65-F5344CB8AC3E}">
-        <p14:creationId xmlns:p14="http://schemas.microsoft.com/office/powerpoint/2010/main" val="1408760485"/>
+        <p14:creationId xmlns:p14="http://schemas.microsoft.com/office/powerpoint/2010/main" val="1501085409"/>
       </p:ext>
     </p:extLst>
   </p:cSld>
@@ -763,7 +763,7 @@
           <a:p>
             <a:fld id="{A251CCDE-328B-3447-911A-D9F0DCC9D8CE}" type="datetimeFigureOut">
               <a:rPr lang="en-US" smtClean="0"/>
-              <a:t>4/11/25</a:t>
+              <a:t>4/23/25</a:t>
             </a:fld>
             <a:endParaRPr lang="en-US"/>
           </a:p>
@@ -814,7 +814,7 @@
     </p:spTree>
     <p:extLst>
       <p:ext uri="{BB962C8B-B14F-4D97-AF65-F5344CB8AC3E}">
-        <p14:creationId xmlns:p14="http://schemas.microsoft.com/office/powerpoint/2010/main" val="2240531231"/>
+        <p14:creationId xmlns:p14="http://schemas.microsoft.com/office/powerpoint/2010/main" val="3569621919"/>
       </p:ext>
     </p:extLst>
   </p:cSld>
@@ -853,15 +853,15 @@
         </p:nvSpPr>
         <p:spPr>
           <a:xfrm>
-            <a:off x="474198" y="2279653"/>
-            <a:ext cx="5994440" cy="3803649"/>
+            <a:off x="461634" y="2222661"/>
+            <a:ext cx="5835610" cy="3708558"/>
           </a:xfrm>
         </p:spPr>
         <p:txBody>
           <a:bodyPr anchor="b"/>
           <a:lstStyle>
             <a:lvl1pPr>
-              <a:defRPr sz="4561"/>
+              <a:defRPr sz="4439"/>
             </a:lvl1pPr>
           </a:lstStyle>
           <a:p>
@@ -885,8 +885,8 @@
         </p:nvSpPr>
         <p:spPr>
           <a:xfrm>
-            <a:off x="474198" y="6119286"/>
-            <a:ext cx="5994440" cy="2000249"/>
+            <a:off x="461634" y="5966304"/>
+            <a:ext cx="5835610" cy="1950243"/>
           </a:xfrm>
         </p:spPr>
         <p:txBody>
@@ -894,7 +894,7 @@
           <a:lstStyle>
             <a:lvl1pPr marL="0" indent="0">
               <a:buNone/>
-              <a:defRPr sz="1824">
+              <a:defRPr sz="1776">
                 <a:solidFill>
                   <a:schemeClr val="tx1">
                     <a:tint val="82000"/>
@@ -902,9 +902,9 @@
                 </a:solidFill>
               </a:defRPr>
             </a:lvl1pPr>
-            <a:lvl2pPr marL="347518" indent="0">
-              <a:buNone/>
-              <a:defRPr sz="1520">
+            <a:lvl2pPr marL="338282" indent="0">
+              <a:buNone/>
+              <a:defRPr sz="1480">
                 <a:solidFill>
                   <a:schemeClr val="tx1">
                     <a:tint val="82000"/>
@@ -912,9 +912,9 @@
                 </a:solidFill>
               </a:defRPr>
             </a:lvl2pPr>
-            <a:lvl3pPr marL="695035" indent="0">
-              <a:buNone/>
-              <a:defRPr sz="1368">
+            <a:lvl3pPr marL="676565" indent="0">
+              <a:buNone/>
+              <a:defRPr sz="1332">
                 <a:solidFill>
                   <a:schemeClr val="tx1">
                     <a:tint val="82000"/>
@@ -922,9 +922,9 @@
                 </a:solidFill>
               </a:defRPr>
             </a:lvl3pPr>
-            <a:lvl4pPr marL="1042553" indent="0">
-              <a:buNone/>
-              <a:defRPr sz="1216">
+            <a:lvl4pPr marL="1014847" indent="0">
+              <a:buNone/>
+              <a:defRPr sz="1184">
                 <a:solidFill>
                   <a:schemeClr val="tx1">
                     <a:tint val="82000"/>
@@ -932,9 +932,9 @@
                 </a:solidFill>
               </a:defRPr>
             </a:lvl4pPr>
-            <a:lvl5pPr marL="1390071" indent="0">
-              <a:buNone/>
-              <a:defRPr sz="1216">
+            <a:lvl5pPr marL="1353129" indent="0">
+              <a:buNone/>
+              <a:defRPr sz="1184">
                 <a:solidFill>
                   <a:schemeClr val="tx1">
                     <a:tint val="82000"/>
@@ -942,9 +942,9 @@
                 </a:solidFill>
               </a:defRPr>
             </a:lvl5pPr>
-            <a:lvl6pPr marL="1737589" indent="0">
-              <a:buNone/>
-              <a:defRPr sz="1216">
+            <a:lvl6pPr marL="1691411" indent="0">
+              <a:buNone/>
+              <a:defRPr sz="1184">
                 <a:solidFill>
                   <a:schemeClr val="tx1">
                     <a:tint val="82000"/>
@@ -952,9 +952,9 @@
                 </a:solidFill>
               </a:defRPr>
             </a:lvl6pPr>
-            <a:lvl7pPr marL="2085106" indent="0">
-              <a:buNone/>
-              <a:defRPr sz="1216">
+            <a:lvl7pPr marL="2029694" indent="0">
+              <a:buNone/>
+              <a:defRPr sz="1184">
                 <a:solidFill>
                   <a:schemeClr val="tx1">
                     <a:tint val="82000"/>
@@ -962,9 +962,9 @@
                 </a:solidFill>
               </a:defRPr>
             </a:lvl7pPr>
-            <a:lvl8pPr marL="2432624" indent="0">
-              <a:buNone/>
-              <a:defRPr sz="1216">
+            <a:lvl8pPr marL="2367976" indent="0">
+              <a:buNone/>
+              <a:defRPr sz="1184">
                 <a:solidFill>
                   <a:schemeClr val="tx1">
                     <a:tint val="82000"/>
@@ -972,9 +972,9 @@
                 </a:solidFill>
               </a:defRPr>
             </a:lvl8pPr>
-            <a:lvl9pPr marL="2780142" indent="0">
-              <a:buNone/>
-              <a:defRPr sz="1216">
+            <a:lvl9pPr marL="2706258" indent="0">
+              <a:buNone/>
+              <a:defRPr sz="1184">
                 <a:solidFill>
                   <a:schemeClr val="tx1">
                     <a:tint val="82000"/>
@@ -1009,7 +1009,7 @@
           <a:p>
             <a:fld id="{A251CCDE-328B-3447-911A-D9F0DCC9D8CE}" type="datetimeFigureOut">
               <a:rPr lang="en-US" smtClean="0"/>
-              <a:t>4/11/25</a:t>
+              <a:t>4/23/25</a:t>
             </a:fld>
             <a:endParaRPr lang="en-US"/>
           </a:p>
@@ -1060,7 +1060,7 @@
     </p:spTree>
     <p:extLst>
       <p:ext uri="{BB962C8B-B14F-4D97-AF65-F5344CB8AC3E}">
-        <p14:creationId xmlns:p14="http://schemas.microsoft.com/office/powerpoint/2010/main" val="3079470360"/>
+        <p14:creationId xmlns:p14="http://schemas.microsoft.com/office/powerpoint/2010/main" val="4231856208"/>
       </p:ext>
     </p:extLst>
   </p:cSld>
@@ -1122,8 +1122,8 @@
         </p:nvSpPr>
         <p:spPr>
           <a:xfrm>
-            <a:off x="477818" y="2434167"/>
-            <a:ext cx="2953782" cy="5801784"/>
+            <a:off x="465157" y="2373313"/>
+            <a:ext cx="2875518" cy="5656739"/>
           </a:xfrm>
         </p:spPr>
         <p:txBody>
@@ -1179,8 +1179,8 @@
         </p:nvSpPr>
         <p:spPr>
           <a:xfrm>
-            <a:off x="3518475" y="2434167"/>
-            <a:ext cx="2953782" cy="5801784"/>
+            <a:off x="3425250" y="2373313"/>
+            <a:ext cx="2875518" cy="5656739"/>
           </a:xfrm>
         </p:spPr>
         <p:txBody>
@@ -1241,7 +1241,7 @@
           <a:p>
             <a:fld id="{A251CCDE-328B-3447-911A-D9F0DCC9D8CE}" type="datetimeFigureOut">
               <a:rPr lang="en-US" smtClean="0"/>
-              <a:t>4/11/25</a:t>
+              <a:t>4/23/25</a:t>
             </a:fld>
             <a:endParaRPr lang="en-US"/>
           </a:p>
@@ -1292,7 +1292,7 @@
     </p:spTree>
     <p:extLst>
       <p:ext uri="{BB962C8B-B14F-4D97-AF65-F5344CB8AC3E}">
-        <p14:creationId xmlns:p14="http://schemas.microsoft.com/office/powerpoint/2010/main" val="3823142027"/>
+        <p14:creationId xmlns:p14="http://schemas.microsoft.com/office/powerpoint/2010/main" val="3226746845"/>
       </p:ext>
     </p:extLst>
   </p:cSld>
@@ -1331,8 +1331,8 @@
         </p:nvSpPr>
         <p:spPr>
           <a:xfrm>
-            <a:off x="478723" y="486835"/>
-            <a:ext cx="5994440" cy="1767417"/>
+            <a:off x="466039" y="474664"/>
+            <a:ext cx="5835610" cy="1723232"/>
           </a:xfrm>
         </p:spPr>
         <p:txBody>
@@ -1359,8 +1359,8 @@
         </p:nvSpPr>
         <p:spPr>
           <a:xfrm>
-            <a:off x="478724" y="2241551"/>
-            <a:ext cx="2940207" cy="1098549"/>
+            <a:off x="466039" y="2185512"/>
+            <a:ext cx="2862303" cy="1071086"/>
           </a:xfrm>
         </p:spPr>
         <p:txBody>
@@ -1368,39 +1368,39 @@
           <a:lstStyle>
             <a:lvl1pPr marL="0" indent="0">
               <a:buNone/>
-              <a:defRPr sz="1824" b="1"/>
+              <a:defRPr sz="1776" b="1"/>
             </a:lvl1pPr>
-            <a:lvl2pPr marL="347518" indent="0">
-              <a:buNone/>
-              <a:defRPr sz="1520" b="1"/>
+            <a:lvl2pPr marL="338282" indent="0">
+              <a:buNone/>
+              <a:defRPr sz="1480" b="1"/>
             </a:lvl2pPr>
-            <a:lvl3pPr marL="695035" indent="0">
-              <a:buNone/>
-              <a:defRPr sz="1368" b="1"/>
+            <a:lvl3pPr marL="676565" indent="0">
+              <a:buNone/>
+              <a:defRPr sz="1332" b="1"/>
             </a:lvl3pPr>
-            <a:lvl4pPr marL="1042553" indent="0">
-              <a:buNone/>
-              <a:defRPr sz="1216" b="1"/>
+            <a:lvl4pPr marL="1014847" indent="0">
+              <a:buNone/>
+              <a:defRPr sz="1184" b="1"/>
             </a:lvl4pPr>
-            <a:lvl5pPr marL="1390071" indent="0">
-              <a:buNone/>
-              <a:defRPr sz="1216" b="1"/>
+            <a:lvl5pPr marL="1353129" indent="0">
+              <a:buNone/>
+              <a:defRPr sz="1184" b="1"/>
             </a:lvl5pPr>
-            <a:lvl6pPr marL="1737589" indent="0">
-              <a:buNone/>
-              <a:defRPr sz="1216" b="1"/>
+            <a:lvl6pPr marL="1691411" indent="0">
+              <a:buNone/>
+              <a:defRPr sz="1184" b="1"/>
             </a:lvl6pPr>
-            <a:lvl7pPr marL="2085106" indent="0">
-              <a:buNone/>
-              <a:defRPr sz="1216" b="1"/>
+            <a:lvl7pPr marL="2029694" indent="0">
+              <a:buNone/>
+              <a:defRPr sz="1184" b="1"/>
             </a:lvl7pPr>
-            <a:lvl8pPr marL="2432624" indent="0">
-              <a:buNone/>
-              <a:defRPr sz="1216" b="1"/>
+            <a:lvl8pPr marL="2367976" indent="0">
+              <a:buNone/>
+              <a:defRPr sz="1184" b="1"/>
             </a:lvl8pPr>
-            <a:lvl9pPr marL="2780142" indent="0">
-              <a:buNone/>
-              <a:defRPr sz="1216" b="1"/>
+            <a:lvl9pPr marL="2706258" indent="0">
+              <a:buNone/>
+              <a:defRPr sz="1184" b="1"/>
             </a:lvl9pPr>
           </a:lstStyle>
           <a:p>
@@ -1424,8 +1424,8 @@
         </p:nvSpPr>
         <p:spPr>
           <a:xfrm>
-            <a:off x="478724" y="3340100"/>
-            <a:ext cx="2940207" cy="4912784"/>
+            <a:off x="466039" y="3256598"/>
+            <a:ext cx="2862303" cy="4789964"/>
           </a:xfrm>
         </p:spPr>
         <p:txBody>
@@ -1481,8 +1481,8 @@
         </p:nvSpPr>
         <p:spPr>
           <a:xfrm>
-            <a:off x="3518476" y="2241551"/>
-            <a:ext cx="2954687" cy="1098549"/>
+            <a:off x="3425250" y="2185512"/>
+            <a:ext cx="2876399" cy="1071086"/>
           </a:xfrm>
         </p:spPr>
         <p:txBody>
@@ -1490,39 +1490,39 @@
           <a:lstStyle>
             <a:lvl1pPr marL="0" indent="0">
               <a:buNone/>
-              <a:defRPr sz="1824" b="1"/>
+              <a:defRPr sz="1776" b="1"/>
             </a:lvl1pPr>
-            <a:lvl2pPr marL="347518" indent="0">
-              <a:buNone/>
-              <a:defRPr sz="1520" b="1"/>
+            <a:lvl2pPr marL="338282" indent="0">
+              <a:buNone/>
+              <a:defRPr sz="1480" b="1"/>
             </a:lvl2pPr>
-            <a:lvl3pPr marL="695035" indent="0">
-              <a:buNone/>
-              <a:defRPr sz="1368" b="1"/>
+            <a:lvl3pPr marL="676565" indent="0">
+              <a:buNone/>
+              <a:defRPr sz="1332" b="1"/>
             </a:lvl3pPr>
-            <a:lvl4pPr marL="1042553" indent="0">
-              <a:buNone/>
-              <a:defRPr sz="1216" b="1"/>
+            <a:lvl4pPr marL="1014847" indent="0">
+              <a:buNone/>
+              <a:defRPr sz="1184" b="1"/>
             </a:lvl4pPr>
-            <a:lvl5pPr marL="1390071" indent="0">
-              <a:buNone/>
-              <a:defRPr sz="1216" b="1"/>
+            <a:lvl5pPr marL="1353129" indent="0">
+              <a:buNone/>
+              <a:defRPr sz="1184" b="1"/>
             </a:lvl5pPr>
-            <a:lvl6pPr marL="1737589" indent="0">
-              <a:buNone/>
-              <a:defRPr sz="1216" b="1"/>
+            <a:lvl6pPr marL="1691411" indent="0">
+              <a:buNone/>
+              <a:defRPr sz="1184" b="1"/>
             </a:lvl6pPr>
-            <a:lvl7pPr marL="2085106" indent="0">
-              <a:buNone/>
-              <a:defRPr sz="1216" b="1"/>
+            <a:lvl7pPr marL="2029694" indent="0">
+              <a:buNone/>
+              <a:defRPr sz="1184" b="1"/>
             </a:lvl7pPr>
-            <a:lvl8pPr marL="2432624" indent="0">
-              <a:buNone/>
-              <a:defRPr sz="1216" b="1"/>
+            <a:lvl8pPr marL="2367976" indent="0">
+              <a:buNone/>
+              <a:defRPr sz="1184" b="1"/>
             </a:lvl8pPr>
-            <a:lvl9pPr marL="2780142" indent="0">
-              <a:buNone/>
-              <a:defRPr sz="1216" b="1"/>
+            <a:lvl9pPr marL="2706258" indent="0">
+              <a:buNone/>
+              <a:defRPr sz="1184" b="1"/>
             </a:lvl9pPr>
           </a:lstStyle>
           <a:p>
@@ -1546,8 +1546,8 @@
         </p:nvSpPr>
         <p:spPr>
           <a:xfrm>
-            <a:off x="3518476" y="3340100"/>
-            <a:ext cx="2954687" cy="4912784"/>
+            <a:off x="3425250" y="3256598"/>
+            <a:ext cx="2876399" cy="4789964"/>
           </a:xfrm>
         </p:spPr>
         <p:txBody>
@@ -1608,7 +1608,7 @@
           <a:p>
             <a:fld id="{A251CCDE-328B-3447-911A-D9F0DCC9D8CE}" type="datetimeFigureOut">
               <a:rPr lang="en-US" smtClean="0"/>
-              <a:t>4/11/25</a:t>
+              <a:t>4/23/25</a:t>
             </a:fld>
             <a:endParaRPr lang="en-US"/>
           </a:p>
@@ -1659,7 +1659,7 @@
     </p:spTree>
     <p:extLst>
       <p:ext uri="{BB962C8B-B14F-4D97-AF65-F5344CB8AC3E}">
-        <p14:creationId xmlns:p14="http://schemas.microsoft.com/office/powerpoint/2010/main" val="848811148"/>
+        <p14:creationId xmlns:p14="http://schemas.microsoft.com/office/powerpoint/2010/main" val="2399809639"/>
       </p:ext>
     </p:extLst>
   </p:cSld>
@@ -1726,7 +1726,7 @@
           <a:p>
             <a:fld id="{A251CCDE-328B-3447-911A-D9F0DCC9D8CE}" type="datetimeFigureOut">
               <a:rPr lang="en-US" smtClean="0"/>
-              <a:t>4/11/25</a:t>
+              <a:t>4/23/25</a:t>
             </a:fld>
             <a:endParaRPr lang="en-US"/>
           </a:p>
@@ -1777,7 +1777,7 @@
     </p:spTree>
     <p:extLst>
       <p:ext uri="{BB962C8B-B14F-4D97-AF65-F5344CB8AC3E}">
-        <p14:creationId xmlns:p14="http://schemas.microsoft.com/office/powerpoint/2010/main" val="3462327168"/>
+        <p14:creationId xmlns:p14="http://schemas.microsoft.com/office/powerpoint/2010/main" val="831520391"/>
       </p:ext>
     </p:extLst>
   </p:cSld>
@@ -1821,7 +1821,7 @@
           <a:p>
             <a:fld id="{A251CCDE-328B-3447-911A-D9F0DCC9D8CE}" type="datetimeFigureOut">
               <a:rPr lang="en-US" smtClean="0"/>
-              <a:t>4/11/25</a:t>
+              <a:t>4/23/25</a:t>
             </a:fld>
             <a:endParaRPr lang="en-US"/>
           </a:p>
@@ -1872,7 +1872,7 @@
     </p:spTree>
     <p:extLst>
       <p:ext uri="{BB962C8B-B14F-4D97-AF65-F5344CB8AC3E}">
-        <p14:creationId xmlns:p14="http://schemas.microsoft.com/office/powerpoint/2010/main" val="3101180634"/>
+        <p14:creationId xmlns:p14="http://schemas.microsoft.com/office/powerpoint/2010/main" val="2164639919"/>
       </p:ext>
     </p:extLst>
   </p:cSld>
@@ -1911,15 +1911,15 @@
         </p:nvSpPr>
         <p:spPr>
           <a:xfrm>
-            <a:off x="478723" y="609600"/>
-            <a:ext cx="2241580" cy="2133600"/>
+            <a:off x="466039" y="594360"/>
+            <a:ext cx="2182187" cy="2080260"/>
           </a:xfrm>
         </p:spPr>
         <p:txBody>
           <a:bodyPr anchor="b"/>
           <a:lstStyle>
             <a:lvl1pPr>
-              <a:defRPr sz="2432"/>
+              <a:defRPr sz="2368"/>
             </a:lvl1pPr>
           </a:lstStyle>
           <a:p>
@@ -1943,39 +1943,39 @@
         </p:nvSpPr>
         <p:spPr>
           <a:xfrm>
-            <a:off x="2954687" y="1316568"/>
-            <a:ext cx="3518475" cy="6498167"/>
+            <a:off x="2876399" y="1283654"/>
+            <a:ext cx="3425250" cy="6335713"/>
           </a:xfrm>
         </p:spPr>
         <p:txBody>
           <a:bodyPr/>
           <a:lstStyle>
             <a:lvl1pPr>
-              <a:defRPr sz="2432"/>
+              <a:defRPr sz="2368"/>
             </a:lvl1pPr>
             <a:lvl2pPr>
-              <a:defRPr sz="2128"/>
+              <a:defRPr sz="2072"/>
             </a:lvl2pPr>
             <a:lvl3pPr>
-              <a:defRPr sz="1824"/>
+              <a:defRPr sz="1776"/>
             </a:lvl3pPr>
             <a:lvl4pPr>
-              <a:defRPr sz="1520"/>
+              <a:defRPr sz="1480"/>
             </a:lvl4pPr>
             <a:lvl5pPr>
-              <a:defRPr sz="1520"/>
+              <a:defRPr sz="1480"/>
             </a:lvl5pPr>
             <a:lvl6pPr>
-              <a:defRPr sz="1520"/>
+              <a:defRPr sz="1480"/>
             </a:lvl6pPr>
             <a:lvl7pPr>
-              <a:defRPr sz="1520"/>
+              <a:defRPr sz="1480"/>
             </a:lvl7pPr>
             <a:lvl8pPr>
-              <a:defRPr sz="1520"/>
+              <a:defRPr sz="1480"/>
             </a:lvl8pPr>
             <a:lvl9pPr>
-              <a:defRPr sz="1520"/>
+              <a:defRPr sz="1480"/>
             </a:lvl9pPr>
           </a:lstStyle>
           <a:p>
@@ -2028,8 +2028,8 @@
         </p:nvSpPr>
         <p:spPr>
           <a:xfrm>
-            <a:off x="478723" y="2743200"/>
-            <a:ext cx="2241580" cy="5082117"/>
+            <a:off x="466039" y="2674620"/>
+            <a:ext cx="2182187" cy="4955064"/>
           </a:xfrm>
         </p:spPr>
         <p:txBody>
@@ -2037,39 +2037,39 @@
           <a:lstStyle>
             <a:lvl1pPr marL="0" indent="0">
               <a:buNone/>
-              <a:defRPr sz="1216"/>
+              <a:defRPr sz="1184"/>
             </a:lvl1pPr>
-            <a:lvl2pPr marL="347518" indent="0">
-              <a:buNone/>
-              <a:defRPr sz="1064"/>
+            <a:lvl2pPr marL="338282" indent="0">
+              <a:buNone/>
+              <a:defRPr sz="1036"/>
             </a:lvl2pPr>
-            <a:lvl3pPr marL="695035" indent="0">
-              <a:buNone/>
-              <a:defRPr sz="912"/>
+            <a:lvl3pPr marL="676565" indent="0">
+              <a:buNone/>
+              <a:defRPr sz="888"/>
             </a:lvl3pPr>
-            <a:lvl4pPr marL="1042553" indent="0">
-              <a:buNone/>
-              <a:defRPr sz="760"/>
+            <a:lvl4pPr marL="1014847" indent="0">
+              <a:buNone/>
+              <a:defRPr sz="740"/>
             </a:lvl4pPr>
-            <a:lvl5pPr marL="1390071" indent="0">
-              <a:buNone/>
-              <a:defRPr sz="760"/>
+            <a:lvl5pPr marL="1353129" indent="0">
+              <a:buNone/>
+              <a:defRPr sz="740"/>
             </a:lvl5pPr>
-            <a:lvl6pPr marL="1737589" indent="0">
-              <a:buNone/>
-              <a:defRPr sz="760"/>
+            <a:lvl6pPr marL="1691411" indent="0">
+              <a:buNone/>
+              <a:defRPr sz="740"/>
             </a:lvl6pPr>
-            <a:lvl7pPr marL="2085106" indent="0">
-              <a:buNone/>
-              <a:defRPr sz="760"/>
+            <a:lvl7pPr marL="2029694" indent="0">
+              <a:buNone/>
+              <a:defRPr sz="740"/>
             </a:lvl7pPr>
-            <a:lvl8pPr marL="2432624" indent="0">
-              <a:buNone/>
-              <a:defRPr sz="760"/>
+            <a:lvl8pPr marL="2367976" indent="0">
+              <a:buNone/>
+              <a:defRPr sz="740"/>
             </a:lvl8pPr>
-            <a:lvl9pPr marL="2780142" indent="0">
-              <a:buNone/>
-              <a:defRPr sz="760"/>
+            <a:lvl9pPr marL="2706258" indent="0">
+              <a:buNone/>
+              <a:defRPr sz="740"/>
             </a:lvl9pPr>
           </a:lstStyle>
           <a:p>
@@ -2098,7 +2098,7 @@
           <a:p>
             <a:fld id="{A251CCDE-328B-3447-911A-D9F0DCC9D8CE}" type="datetimeFigureOut">
               <a:rPr lang="en-US" smtClean="0"/>
-              <a:t>4/11/25</a:t>
+              <a:t>4/23/25</a:t>
             </a:fld>
             <a:endParaRPr lang="en-US"/>
           </a:p>
@@ -2149,7 +2149,7 @@
     </p:spTree>
     <p:extLst>
       <p:ext uri="{BB962C8B-B14F-4D97-AF65-F5344CB8AC3E}">
-        <p14:creationId xmlns:p14="http://schemas.microsoft.com/office/powerpoint/2010/main" val="1249803086"/>
+        <p14:creationId xmlns:p14="http://schemas.microsoft.com/office/powerpoint/2010/main" val="1237019409"/>
       </p:ext>
     </p:extLst>
   </p:cSld>
@@ -2188,15 +2188,15 @@
         </p:nvSpPr>
         <p:spPr>
           <a:xfrm>
-            <a:off x="478723" y="609600"/>
-            <a:ext cx="2241580" cy="2133600"/>
+            <a:off x="466039" y="594360"/>
+            <a:ext cx="2182187" cy="2080260"/>
           </a:xfrm>
         </p:spPr>
         <p:txBody>
           <a:bodyPr anchor="b"/>
           <a:lstStyle>
             <a:lvl1pPr>
-              <a:defRPr sz="2432"/>
+              <a:defRPr sz="2368"/>
             </a:lvl1pPr>
           </a:lstStyle>
           <a:p>
@@ -2220,8 +2220,8 @@
         </p:nvSpPr>
         <p:spPr>
           <a:xfrm>
-            <a:off x="2954687" y="1316568"/>
-            <a:ext cx="3518475" cy="6498167"/>
+            <a:off x="2876399" y="1283654"/>
+            <a:ext cx="3425250" cy="6335713"/>
           </a:xfrm>
         </p:spPr>
         <p:txBody>
@@ -2229,39 +2229,39 @@
           <a:lstStyle>
             <a:lvl1pPr marL="0" indent="0">
               <a:buNone/>
-              <a:defRPr sz="2432"/>
+              <a:defRPr sz="2368"/>
             </a:lvl1pPr>
-            <a:lvl2pPr marL="347518" indent="0">
-              <a:buNone/>
-              <a:defRPr sz="2128"/>
+            <a:lvl2pPr marL="338282" indent="0">
+              <a:buNone/>
+              <a:defRPr sz="2072"/>
             </a:lvl2pPr>
-            <a:lvl3pPr marL="695035" indent="0">
-              <a:buNone/>
-              <a:defRPr sz="1824"/>
+            <a:lvl3pPr marL="676565" indent="0">
+              <a:buNone/>
+              <a:defRPr sz="1776"/>
             </a:lvl3pPr>
-            <a:lvl4pPr marL="1042553" indent="0">
-              <a:buNone/>
-              <a:defRPr sz="1520"/>
+            <a:lvl4pPr marL="1014847" indent="0">
+              <a:buNone/>
+              <a:defRPr sz="1480"/>
             </a:lvl4pPr>
-            <a:lvl5pPr marL="1390071" indent="0">
-              <a:buNone/>
-              <a:defRPr sz="1520"/>
+            <a:lvl5pPr marL="1353129" indent="0">
+              <a:buNone/>
+              <a:defRPr sz="1480"/>
             </a:lvl5pPr>
-            <a:lvl6pPr marL="1737589" indent="0">
-              <a:buNone/>
-              <a:defRPr sz="1520"/>
+            <a:lvl6pPr marL="1691411" indent="0">
+              <a:buNone/>
+              <a:defRPr sz="1480"/>
             </a:lvl6pPr>
-            <a:lvl7pPr marL="2085106" indent="0">
-              <a:buNone/>
-              <a:defRPr sz="1520"/>
+            <a:lvl7pPr marL="2029694" indent="0">
+              <a:buNone/>
+              <a:defRPr sz="1480"/>
             </a:lvl7pPr>
-            <a:lvl8pPr marL="2432624" indent="0">
-              <a:buNone/>
-              <a:defRPr sz="1520"/>
+            <a:lvl8pPr marL="2367976" indent="0">
+              <a:buNone/>
+              <a:defRPr sz="1480"/>
             </a:lvl8pPr>
-            <a:lvl9pPr marL="2780142" indent="0">
-              <a:buNone/>
-              <a:defRPr sz="1520"/>
+            <a:lvl9pPr marL="2706258" indent="0">
+              <a:buNone/>
+              <a:defRPr sz="1480"/>
             </a:lvl9pPr>
           </a:lstStyle>
           <a:p>
@@ -2285,8 +2285,8 @@
         </p:nvSpPr>
         <p:spPr>
           <a:xfrm>
-            <a:off x="478723" y="2743200"/>
-            <a:ext cx="2241580" cy="5082117"/>
+            <a:off x="466039" y="2674620"/>
+            <a:ext cx="2182187" cy="4955064"/>
           </a:xfrm>
         </p:spPr>
         <p:txBody>
@@ -2294,39 +2294,39 @@
           <a:lstStyle>
             <a:lvl1pPr marL="0" indent="0">
               <a:buNone/>
-              <a:defRPr sz="1216"/>
+              <a:defRPr sz="1184"/>
             </a:lvl1pPr>
-            <a:lvl2pPr marL="347518" indent="0">
-              <a:buNone/>
-              <a:defRPr sz="1064"/>
+            <a:lvl2pPr marL="338282" indent="0">
+              <a:buNone/>
+              <a:defRPr sz="1036"/>
             </a:lvl2pPr>
-            <a:lvl3pPr marL="695035" indent="0">
-              <a:buNone/>
-              <a:defRPr sz="912"/>
+            <a:lvl3pPr marL="676565" indent="0">
+              <a:buNone/>
+              <a:defRPr sz="888"/>
             </a:lvl3pPr>
-            <a:lvl4pPr marL="1042553" indent="0">
-              <a:buNone/>
-              <a:defRPr sz="760"/>
+            <a:lvl4pPr marL="1014847" indent="0">
+              <a:buNone/>
+              <a:defRPr sz="740"/>
             </a:lvl4pPr>
-            <a:lvl5pPr marL="1390071" indent="0">
-              <a:buNone/>
-              <a:defRPr sz="760"/>
+            <a:lvl5pPr marL="1353129" indent="0">
+              <a:buNone/>
+              <a:defRPr sz="740"/>
             </a:lvl5pPr>
-            <a:lvl6pPr marL="1737589" indent="0">
-              <a:buNone/>
-              <a:defRPr sz="760"/>
+            <a:lvl6pPr marL="1691411" indent="0">
+              <a:buNone/>
+              <a:defRPr sz="740"/>
             </a:lvl6pPr>
-            <a:lvl7pPr marL="2085106" indent="0">
-              <a:buNone/>
-              <a:defRPr sz="760"/>
+            <a:lvl7pPr marL="2029694" indent="0">
+              <a:buNone/>
+              <a:defRPr sz="740"/>
             </a:lvl7pPr>
-            <a:lvl8pPr marL="2432624" indent="0">
-              <a:buNone/>
-              <a:defRPr sz="760"/>
+            <a:lvl8pPr marL="2367976" indent="0">
+              <a:buNone/>
+              <a:defRPr sz="740"/>
             </a:lvl8pPr>
-            <a:lvl9pPr marL="2780142" indent="0">
-              <a:buNone/>
-              <a:defRPr sz="760"/>
+            <a:lvl9pPr marL="2706258" indent="0">
+              <a:buNone/>
+              <a:defRPr sz="740"/>
             </a:lvl9pPr>
           </a:lstStyle>
           <a:p>
@@ -2355,7 +2355,7 @@
           <a:p>
             <a:fld id="{A251CCDE-328B-3447-911A-D9F0DCC9D8CE}" type="datetimeFigureOut">
               <a:rPr lang="en-US" smtClean="0"/>
-              <a:t>4/11/25</a:t>
+              <a:t>4/23/25</a:t>
             </a:fld>
             <a:endParaRPr lang="en-US"/>
           </a:p>
@@ -2406,7 +2406,7 @@
     </p:spTree>
     <p:extLst>
       <p:ext uri="{BB962C8B-B14F-4D97-AF65-F5344CB8AC3E}">
-        <p14:creationId xmlns:p14="http://schemas.microsoft.com/office/powerpoint/2010/main" val="1193838747"/>
+        <p14:creationId xmlns:p14="http://schemas.microsoft.com/office/powerpoint/2010/main" val="1676733163"/>
       </p:ext>
     </p:extLst>
   </p:cSld>
@@ -2450,8 +2450,8 @@
         </p:nvSpPr>
         <p:spPr>
           <a:xfrm>
-            <a:off x="477818" y="486835"/>
-            <a:ext cx="5994440" cy="1767417"/>
+            <a:off x="465158" y="474664"/>
+            <a:ext cx="5835610" cy="1723232"/>
           </a:xfrm>
           <a:prstGeom prst="rect">
             <a:avLst/>
@@ -2483,8 +2483,8 @@
         </p:nvSpPr>
         <p:spPr>
           <a:xfrm>
-            <a:off x="477818" y="2434167"/>
-            <a:ext cx="5994440" cy="5801784"/>
+            <a:off x="465158" y="2373313"/>
+            <a:ext cx="5835610" cy="5656739"/>
           </a:xfrm>
           <a:prstGeom prst="rect">
             <a:avLst/>
@@ -2545,8 +2545,8 @@
         </p:nvSpPr>
         <p:spPr>
           <a:xfrm>
-            <a:off x="477818" y="8475136"/>
-            <a:ext cx="1563767" cy="486833"/>
+            <a:off x="465157" y="8263257"/>
+            <a:ext cx="1522333" cy="474663"/>
           </a:xfrm>
           <a:prstGeom prst="rect">
             <a:avLst/>
@@ -2556,7 +2556,7 @@
           <a:bodyPr vert="horz" lIns="91440" tIns="45720" rIns="91440" bIns="45720" rtlCol="0" anchor="ctr"/>
           <a:lstStyle>
             <a:lvl1pPr algn="l">
-              <a:defRPr sz="912">
+              <a:defRPr sz="888">
                 <a:solidFill>
                   <a:schemeClr val="tx1">
                     <a:tint val="82000"/>
@@ -2568,7 +2568,7 @@
           <a:p>
             <a:fld id="{A251CCDE-328B-3447-911A-D9F0DCC9D8CE}" type="datetimeFigureOut">
               <a:rPr lang="en-US" smtClean="0"/>
-              <a:t>4/11/25</a:t>
+              <a:t>4/23/25</a:t>
             </a:fld>
             <a:endParaRPr lang="en-US"/>
           </a:p>
@@ -2586,8 +2586,8 @@
         </p:nvSpPr>
         <p:spPr>
           <a:xfrm>
-            <a:off x="2302213" y="8475136"/>
-            <a:ext cx="2345650" cy="486833"/>
+            <a:off x="2241213" y="8263257"/>
+            <a:ext cx="2283500" cy="474663"/>
           </a:xfrm>
           <a:prstGeom prst="rect">
             <a:avLst/>
@@ -2597,7 +2597,7 @@
           <a:bodyPr vert="horz" lIns="91440" tIns="45720" rIns="91440" bIns="45720" rtlCol="0" anchor="ctr"/>
           <a:lstStyle>
             <a:lvl1pPr algn="ctr">
-              <a:defRPr sz="912">
+              <a:defRPr sz="888">
                 <a:solidFill>
                   <a:schemeClr val="tx1">
                     <a:tint val="82000"/>
@@ -2623,8 +2623,8 @@
         </p:nvSpPr>
         <p:spPr>
           <a:xfrm>
-            <a:off x="4908490" y="8475136"/>
-            <a:ext cx="1563767" cy="486833"/>
+            <a:off x="4778435" y="8263257"/>
+            <a:ext cx="1522333" cy="474663"/>
           </a:xfrm>
           <a:prstGeom prst="rect">
             <a:avLst/>
@@ -2634,7 +2634,7 @@
           <a:bodyPr vert="horz" lIns="91440" tIns="45720" rIns="91440" bIns="45720" rtlCol="0" anchor="ctr"/>
           <a:lstStyle>
             <a:lvl1pPr algn="r">
-              <a:defRPr sz="912">
+              <a:defRPr sz="888">
                 <a:solidFill>
                   <a:schemeClr val="tx1">
                     <a:tint val="82000"/>
@@ -2655,27 +2655,27 @@
     </p:spTree>
     <p:extLst>
       <p:ext uri="{BB962C8B-B14F-4D97-AF65-F5344CB8AC3E}">
-        <p14:creationId xmlns:p14="http://schemas.microsoft.com/office/powerpoint/2010/main" val="2076258020"/>
+        <p14:creationId xmlns:p14="http://schemas.microsoft.com/office/powerpoint/2010/main" val="46426502"/>
       </p:ext>
     </p:extLst>
   </p:cSld>
   <p:clrMap bg1="lt1" tx1="dk1" bg2="lt2" tx2="dk2" accent1="accent1" accent2="accent2" accent3="accent3" accent4="accent4" accent5="accent5" accent6="accent6" hlink="hlink" folHlink="folHlink"/>
   <p:sldLayoutIdLst>
-    <p:sldLayoutId id="2147483757" r:id="rId1"/>
-    <p:sldLayoutId id="2147483758" r:id="rId2"/>
-    <p:sldLayoutId id="2147483759" r:id="rId3"/>
-    <p:sldLayoutId id="2147483760" r:id="rId4"/>
-    <p:sldLayoutId id="2147483761" r:id="rId5"/>
-    <p:sldLayoutId id="2147483762" r:id="rId6"/>
-    <p:sldLayoutId id="2147483763" r:id="rId7"/>
-    <p:sldLayoutId id="2147483764" r:id="rId8"/>
-    <p:sldLayoutId id="2147483765" r:id="rId9"/>
-    <p:sldLayoutId id="2147483766" r:id="rId10"/>
-    <p:sldLayoutId id="2147483767" r:id="rId11"/>
+    <p:sldLayoutId id="2147483805" r:id="rId1"/>
+    <p:sldLayoutId id="2147483806" r:id="rId2"/>
+    <p:sldLayoutId id="2147483807" r:id="rId3"/>
+    <p:sldLayoutId id="2147483808" r:id="rId4"/>
+    <p:sldLayoutId id="2147483809" r:id="rId5"/>
+    <p:sldLayoutId id="2147483810" r:id="rId6"/>
+    <p:sldLayoutId id="2147483811" r:id="rId7"/>
+    <p:sldLayoutId id="2147483812" r:id="rId8"/>
+    <p:sldLayoutId id="2147483813" r:id="rId9"/>
+    <p:sldLayoutId id="2147483814" r:id="rId10"/>
+    <p:sldLayoutId id="2147483815" r:id="rId11"/>
   </p:sldLayoutIdLst>
   <p:txStyles>
     <p:titleStyle>
-      <a:lvl1pPr algn="l" defTabSz="695035" rtl="0" eaLnBrk="1" latinLnBrk="0" hangingPunct="1">
+      <a:lvl1pPr algn="l" defTabSz="676565" rtl="0" eaLnBrk="1" latinLnBrk="0" hangingPunct="1">
         <a:lnSpc>
           <a:spcPct val="90000"/>
         </a:lnSpc>
@@ -2683,7 +2683,7 @@
           <a:spcPct val="0"/>
         </a:spcBef>
         <a:buNone/>
-        <a:defRPr sz="3344" kern="1200">
+        <a:defRPr sz="3256" kern="1200">
           <a:solidFill>
             <a:schemeClr val="tx1"/>
           </a:solidFill>
@@ -2694,16 +2694,16 @@
       </a:lvl1pPr>
     </p:titleStyle>
     <p:bodyStyle>
-      <a:lvl1pPr marL="173759" indent="-173759" algn="l" defTabSz="695035" rtl="0" eaLnBrk="1" latinLnBrk="0" hangingPunct="1">
+      <a:lvl1pPr marL="169141" indent="-169141" algn="l" defTabSz="676565" rtl="0" eaLnBrk="1" latinLnBrk="0" hangingPunct="1">
         <a:lnSpc>
           <a:spcPct val="90000"/>
         </a:lnSpc>
         <a:spcBef>
-          <a:spcPts val="760"/>
+          <a:spcPts val="740"/>
         </a:spcBef>
         <a:buFont typeface="Arial" panose="020B0604020202020204" pitchFamily="34" charset="0"/>
         <a:buChar char="•"/>
-        <a:defRPr sz="2128" kern="1200">
+        <a:defRPr sz="2072" kern="1200">
           <a:solidFill>
             <a:schemeClr val="tx1"/>
           </a:solidFill>
@@ -2712,16 +2712,16 @@
           <a:cs typeface="+mn-cs"/>
         </a:defRPr>
       </a:lvl1pPr>
-      <a:lvl2pPr marL="521277" indent="-173759" algn="l" defTabSz="695035" rtl="0" eaLnBrk="1" latinLnBrk="0" hangingPunct="1">
+      <a:lvl2pPr marL="507423" indent="-169141" algn="l" defTabSz="676565" rtl="0" eaLnBrk="1" latinLnBrk="0" hangingPunct="1">
         <a:lnSpc>
           <a:spcPct val="90000"/>
         </a:lnSpc>
         <a:spcBef>
-          <a:spcPts val="380"/>
+          <a:spcPts val="370"/>
         </a:spcBef>
         <a:buFont typeface="Arial" panose="020B0604020202020204" pitchFamily="34" charset="0"/>
         <a:buChar char="•"/>
-        <a:defRPr sz="1824" kern="1200">
+        <a:defRPr sz="1776" kern="1200">
           <a:solidFill>
             <a:schemeClr val="tx1"/>
           </a:solidFill>
@@ -2730,16 +2730,16 @@
           <a:cs typeface="+mn-cs"/>
         </a:defRPr>
       </a:lvl2pPr>
-      <a:lvl3pPr marL="868794" indent="-173759" algn="l" defTabSz="695035" rtl="0" eaLnBrk="1" latinLnBrk="0" hangingPunct="1">
+      <a:lvl3pPr marL="845706" indent="-169141" algn="l" defTabSz="676565" rtl="0" eaLnBrk="1" latinLnBrk="0" hangingPunct="1">
         <a:lnSpc>
           <a:spcPct val="90000"/>
         </a:lnSpc>
         <a:spcBef>
-          <a:spcPts val="380"/>
+          <a:spcPts val="370"/>
         </a:spcBef>
         <a:buFont typeface="Arial" panose="020B0604020202020204" pitchFamily="34" charset="0"/>
         <a:buChar char="•"/>
-        <a:defRPr sz="1520" kern="1200">
+        <a:defRPr sz="1480" kern="1200">
           <a:solidFill>
             <a:schemeClr val="tx1"/>
           </a:solidFill>
@@ -2748,16 +2748,16 @@
           <a:cs typeface="+mn-cs"/>
         </a:defRPr>
       </a:lvl3pPr>
-      <a:lvl4pPr marL="1216312" indent="-173759" algn="l" defTabSz="695035" rtl="0" eaLnBrk="1" latinLnBrk="0" hangingPunct="1">
+      <a:lvl4pPr marL="1183988" indent="-169141" algn="l" defTabSz="676565" rtl="0" eaLnBrk="1" latinLnBrk="0" hangingPunct="1">
         <a:lnSpc>
           <a:spcPct val="90000"/>
         </a:lnSpc>
         <a:spcBef>
-          <a:spcPts val="380"/>
+          <a:spcPts val="370"/>
         </a:spcBef>
         <a:buFont typeface="Arial" panose="020B0604020202020204" pitchFamily="34" charset="0"/>
         <a:buChar char="•"/>
-        <a:defRPr sz="1368" kern="1200">
+        <a:defRPr sz="1332" kern="1200">
           <a:solidFill>
             <a:schemeClr val="tx1"/>
           </a:solidFill>
@@ -2766,16 +2766,16 @@
           <a:cs typeface="+mn-cs"/>
         </a:defRPr>
       </a:lvl4pPr>
-      <a:lvl5pPr marL="1563830" indent="-173759" algn="l" defTabSz="695035" rtl="0" eaLnBrk="1" latinLnBrk="0" hangingPunct="1">
+      <a:lvl5pPr marL="1522270" indent="-169141" algn="l" defTabSz="676565" rtl="0" eaLnBrk="1" latinLnBrk="0" hangingPunct="1">
         <a:lnSpc>
           <a:spcPct val="90000"/>
         </a:lnSpc>
         <a:spcBef>
-          <a:spcPts val="380"/>
+          <a:spcPts val="370"/>
         </a:spcBef>
         <a:buFont typeface="Arial" panose="020B0604020202020204" pitchFamily="34" charset="0"/>
         <a:buChar char="•"/>
-        <a:defRPr sz="1368" kern="1200">
+        <a:defRPr sz="1332" kern="1200">
           <a:solidFill>
             <a:schemeClr val="tx1"/>
           </a:solidFill>
@@ -2784,16 +2784,16 @@
           <a:cs typeface="+mn-cs"/>
         </a:defRPr>
       </a:lvl5pPr>
-      <a:lvl6pPr marL="1911347" indent="-173759" algn="l" defTabSz="695035" rtl="0" eaLnBrk="1" latinLnBrk="0" hangingPunct="1">
+      <a:lvl6pPr marL="1860553" indent="-169141" algn="l" defTabSz="676565" rtl="0" eaLnBrk="1" latinLnBrk="0" hangingPunct="1">
         <a:lnSpc>
           <a:spcPct val="90000"/>
         </a:lnSpc>
         <a:spcBef>
-          <a:spcPts val="380"/>
+          <a:spcPts val="370"/>
         </a:spcBef>
         <a:buFont typeface="Arial" panose="020B0604020202020204" pitchFamily="34" charset="0"/>
         <a:buChar char="•"/>
-        <a:defRPr sz="1368" kern="1200">
+        <a:defRPr sz="1332" kern="1200">
           <a:solidFill>
             <a:schemeClr val="tx1"/>
           </a:solidFill>
@@ -2802,16 +2802,16 @@
           <a:cs typeface="+mn-cs"/>
         </a:defRPr>
       </a:lvl6pPr>
-      <a:lvl7pPr marL="2258865" indent="-173759" algn="l" defTabSz="695035" rtl="0" eaLnBrk="1" latinLnBrk="0" hangingPunct="1">
+      <a:lvl7pPr marL="2198835" indent="-169141" algn="l" defTabSz="676565" rtl="0" eaLnBrk="1" latinLnBrk="0" hangingPunct="1">
         <a:lnSpc>
           <a:spcPct val="90000"/>
         </a:lnSpc>
         <a:spcBef>
-          <a:spcPts val="380"/>
+          <a:spcPts val="370"/>
         </a:spcBef>
         <a:buFont typeface="Arial" panose="020B0604020202020204" pitchFamily="34" charset="0"/>
         <a:buChar char="•"/>
-        <a:defRPr sz="1368" kern="1200">
+        <a:defRPr sz="1332" kern="1200">
           <a:solidFill>
             <a:schemeClr val="tx1"/>
           </a:solidFill>
@@ -2820,16 +2820,16 @@
           <a:cs typeface="+mn-cs"/>
         </a:defRPr>
       </a:lvl7pPr>
-      <a:lvl8pPr marL="2606383" indent="-173759" algn="l" defTabSz="695035" rtl="0" eaLnBrk="1" latinLnBrk="0" hangingPunct="1">
+      <a:lvl8pPr marL="2537117" indent="-169141" algn="l" defTabSz="676565" rtl="0" eaLnBrk="1" latinLnBrk="0" hangingPunct="1">
         <a:lnSpc>
           <a:spcPct val="90000"/>
         </a:lnSpc>
         <a:spcBef>
-          <a:spcPts val="380"/>
+          <a:spcPts val="370"/>
         </a:spcBef>
         <a:buFont typeface="Arial" panose="020B0604020202020204" pitchFamily="34" charset="0"/>
         <a:buChar char="•"/>
-        <a:defRPr sz="1368" kern="1200">
+        <a:defRPr sz="1332" kern="1200">
           <a:solidFill>
             <a:schemeClr val="tx1"/>
           </a:solidFill>
@@ -2838,16 +2838,16 @@
           <a:cs typeface="+mn-cs"/>
         </a:defRPr>
       </a:lvl8pPr>
-      <a:lvl9pPr marL="2953901" indent="-173759" algn="l" defTabSz="695035" rtl="0" eaLnBrk="1" latinLnBrk="0" hangingPunct="1">
+      <a:lvl9pPr marL="2875399" indent="-169141" algn="l" defTabSz="676565" rtl="0" eaLnBrk="1" latinLnBrk="0" hangingPunct="1">
         <a:lnSpc>
           <a:spcPct val="90000"/>
         </a:lnSpc>
         <a:spcBef>
-          <a:spcPts val="380"/>
+          <a:spcPts val="370"/>
         </a:spcBef>
         <a:buFont typeface="Arial" panose="020B0604020202020204" pitchFamily="34" charset="0"/>
         <a:buChar char="•"/>
-        <a:defRPr sz="1368" kern="1200">
+        <a:defRPr sz="1332" kern="1200">
           <a:solidFill>
             <a:schemeClr val="tx1"/>
           </a:solidFill>
@@ -2861,8 +2861,8 @@
       <a:defPPr>
         <a:defRPr lang="en-US"/>
       </a:defPPr>
-      <a:lvl1pPr marL="0" algn="l" defTabSz="695035" rtl="0" eaLnBrk="1" latinLnBrk="0" hangingPunct="1">
-        <a:defRPr sz="1368" kern="1200">
+      <a:lvl1pPr marL="0" algn="l" defTabSz="676565" rtl="0" eaLnBrk="1" latinLnBrk="0" hangingPunct="1">
+        <a:defRPr sz="1332" kern="1200">
           <a:solidFill>
             <a:schemeClr val="tx1"/>
           </a:solidFill>
@@ -2871,8 +2871,8 @@
           <a:cs typeface="+mn-cs"/>
         </a:defRPr>
       </a:lvl1pPr>
-      <a:lvl2pPr marL="347518" algn="l" defTabSz="695035" rtl="0" eaLnBrk="1" latinLnBrk="0" hangingPunct="1">
-        <a:defRPr sz="1368" kern="1200">
+      <a:lvl2pPr marL="338282" algn="l" defTabSz="676565" rtl="0" eaLnBrk="1" latinLnBrk="0" hangingPunct="1">
+        <a:defRPr sz="1332" kern="1200">
           <a:solidFill>
             <a:schemeClr val="tx1"/>
           </a:solidFill>
@@ -2881,8 +2881,8 @@
           <a:cs typeface="+mn-cs"/>
         </a:defRPr>
       </a:lvl2pPr>
-      <a:lvl3pPr marL="695035" algn="l" defTabSz="695035" rtl="0" eaLnBrk="1" latinLnBrk="0" hangingPunct="1">
-        <a:defRPr sz="1368" kern="1200">
+      <a:lvl3pPr marL="676565" algn="l" defTabSz="676565" rtl="0" eaLnBrk="1" latinLnBrk="0" hangingPunct="1">
+        <a:defRPr sz="1332" kern="1200">
           <a:solidFill>
             <a:schemeClr val="tx1"/>
           </a:solidFill>
@@ -2891,8 +2891,8 @@
           <a:cs typeface="+mn-cs"/>
         </a:defRPr>
       </a:lvl3pPr>
-      <a:lvl4pPr marL="1042553" algn="l" defTabSz="695035" rtl="0" eaLnBrk="1" latinLnBrk="0" hangingPunct="1">
-        <a:defRPr sz="1368" kern="1200">
+      <a:lvl4pPr marL="1014847" algn="l" defTabSz="676565" rtl="0" eaLnBrk="1" latinLnBrk="0" hangingPunct="1">
+        <a:defRPr sz="1332" kern="1200">
           <a:solidFill>
             <a:schemeClr val="tx1"/>
           </a:solidFill>
@@ -2901,8 +2901,8 @@
           <a:cs typeface="+mn-cs"/>
         </a:defRPr>
       </a:lvl4pPr>
-      <a:lvl5pPr marL="1390071" algn="l" defTabSz="695035" rtl="0" eaLnBrk="1" latinLnBrk="0" hangingPunct="1">
-        <a:defRPr sz="1368" kern="1200">
+      <a:lvl5pPr marL="1353129" algn="l" defTabSz="676565" rtl="0" eaLnBrk="1" latinLnBrk="0" hangingPunct="1">
+        <a:defRPr sz="1332" kern="1200">
           <a:solidFill>
             <a:schemeClr val="tx1"/>
           </a:solidFill>
@@ -2911,8 +2911,8 @@
           <a:cs typeface="+mn-cs"/>
         </a:defRPr>
       </a:lvl5pPr>
-      <a:lvl6pPr marL="1737589" algn="l" defTabSz="695035" rtl="0" eaLnBrk="1" latinLnBrk="0" hangingPunct="1">
-        <a:defRPr sz="1368" kern="1200">
+      <a:lvl6pPr marL="1691411" algn="l" defTabSz="676565" rtl="0" eaLnBrk="1" latinLnBrk="0" hangingPunct="1">
+        <a:defRPr sz="1332" kern="1200">
           <a:solidFill>
             <a:schemeClr val="tx1"/>
           </a:solidFill>
@@ -2921,8 +2921,8 @@
           <a:cs typeface="+mn-cs"/>
         </a:defRPr>
       </a:lvl6pPr>
-      <a:lvl7pPr marL="2085106" algn="l" defTabSz="695035" rtl="0" eaLnBrk="1" latinLnBrk="0" hangingPunct="1">
-        <a:defRPr sz="1368" kern="1200">
+      <a:lvl7pPr marL="2029694" algn="l" defTabSz="676565" rtl="0" eaLnBrk="1" latinLnBrk="0" hangingPunct="1">
+        <a:defRPr sz="1332" kern="1200">
           <a:solidFill>
             <a:schemeClr val="tx1"/>
           </a:solidFill>
@@ -2931,8 +2931,8 @@
           <a:cs typeface="+mn-cs"/>
         </a:defRPr>
       </a:lvl7pPr>
-      <a:lvl8pPr marL="2432624" algn="l" defTabSz="695035" rtl="0" eaLnBrk="1" latinLnBrk="0" hangingPunct="1">
-        <a:defRPr sz="1368" kern="1200">
+      <a:lvl8pPr marL="2367976" algn="l" defTabSz="676565" rtl="0" eaLnBrk="1" latinLnBrk="0" hangingPunct="1">
+        <a:defRPr sz="1332" kern="1200">
           <a:solidFill>
             <a:schemeClr val="tx1"/>
           </a:solidFill>
@@ -2941,8 +2941,8 @@
           <a:cs typeface="+mn-cs"/>
         </a:defRPr>
       </a:lvl8pPr>
-      <a:lvl9pPr marL="2780142" algn="l" defTabSz="695035" rtl="0" eaLnBrk="1" latinLnBrk="0" hangingPunct="1">
-        <a:defRPr sz="1368" kern="1200">
+      <a:lvl9pPr marL="2706258" algn="l" defTabSz="676565" rtl="0" eaLnBrk="1" latinLnBrk="0" hangingPunct="1">
+        <a:defRPr sz="1332" kern="1200">
           <a:solidFill>
             <a:schemeClr val="tx1"/>
           </a:solidFill>
@@ -2975,10 +2975,10 @@
       </p:grpSpPr>
       <p:pic>
         <p:nvPicPr>
-          <p:cNvPr id="34" name="Picture 33">
+          <p:cNvPr id="3" name="Picture 2" descr="A graph of different colors&#10;&#10;Description automatically generated with medium confidence">
             <a:extLst>
               <a:ext uri="{FF2B5EF4-FFF2-40B4-BE49-F238E27FC236}">
-                <a16:creationId xmlns:a16="http://schemas.microsoft.com/office/drawing/2014/main" id="{E28D8898-B37F-FA7F-9953-C4C04836744C}"/>
+                <a16:creationId xmlns:a16="http://schemas.microsoft.com/office/drawing/2014/main" id="{99CD1E41-98E9-A1F1-1AE4-72D47553B7F3}"/>
               </a:ext>
             </a:extLst>
           </p:cNvPr>
@@ -2989,13 +2989,13 @@
         </p:nvPicPr>
         <p:blipFill>
           <a:blip r:embed="rId2"/>
-          <a:srcRect t="2665" b="1220"/>
+          <a:srcRect t="2222" b="277"/>
           <a:stretch/>
         </p:blipFill>
         <p:spPr>
           <a:xfrm>
-            <a:off x="0" y="84668"/>
-            <a:ext cx="6967242" cy="9008533"/>
+            <a:off x="-46038" y="0"/>
+            <a:ext cx="6797310" cy="8915400"/>
           </a:xfrm>
           <a:prstGeom prst="rect">
             <a:avLst/>
@@ -3016,7 +3016,7 @@
         </p:nvSpPr>
         <p:spPr>
           <a:xfrm>
-            <a:off x="1715236" y="4693174"/>
+            <a:off x="822537" y="4794773"/>
             <a:ext cx="864339" cy="400110"/>
           </a:xfrm>
           <a:prstGeom prst="rect">
@@ -3083,7 +3083,7 @@
         </p:nvSpPr>
         <p:spPr>
           <a:xfrm>
-            <a:off x="615083" y="3804345"/>
+            <a:off x="535183" y="3651944"/>
             <a:ext cx="800219" cy="400110"/>
           </a:xfrm>
           <a:prstGeom prst="rect">
@@ -3150,7 +3150,7 @@
         </p:nvSpPr>
         <p:spPr>
           <a:xfrm>
-            <a:off x="1218341" y="4152965"/>
+            <a:off x="1138441" y="4000564"/>
             <a:ext cx="864339" cy="400110"/>
           </a:xfrm>
           <a:prstGeom prst="rect">
@@ -3227,7 +3227,7 @@
         </p:blipFill>
         <p:spPr>
           <a:xfrm>
-            <a:off x="2901300" y="5527198"/>
+            <a:off x="2685936" y="5374801"/>
             <a:ext cx="1766065" cy="1813079"/>
           </a:xfrm>
           <a:prstGeom prst="rect">
@@ -3256,7 +3256,7 @@
         </p:blipFill>
         <p:spPr>
           <a:xfrm>
-            <a:off x="4994484" y="5701178"/>
+            <a:off x="4779116" y="5548781"/>
             <a:ext cx="1916992" cy="1639099"/>
           </a:xfrm>
           <a:prstGeom prst="rect">
@@ -3285,7 +3285,7 @@
         </p:blipFill>
         <p:spPr>
           <a:xfrm>
-            <a:off x="5038979" y="3673122"/>
+            <a:off x="4823615" y="3520721"/>
             <a:ext cx="1885207" cy="1734506"/>
           </a:xfrm>
           <a:prstGeom prst="rect">
@@ -3314,7 +3314,7 @@
         </p:blipFill>
         <p:spPr>
           <a:xfrm>
-            <a:off x="2902864" y="3678953"/>
+            <a:off x="2687496" y="3526552"/>
             <a:ext cx="1764496" cy="1734506"/>
           </a:xfrm>
           <a:prstGeom prst="rect">
@@ -3336,7 +3336,7 @@
         </p:nvSpPr>
         <p:spPr>
           <a:xfrm>
-            <a:off x="2502642" y="5543054"/>
+            <a:off x="2287274" y="5390653"/>
             <a:ext cx="2164718" cy="1797218"/>
           </a:xfrm>
           <a:prstGeom prst="rect">
@@ -3390,7 +3390,7 @@
         </p:nvSpPr>
         <p:spPr>
           <a:xfrm>
-            <a:off x="2502642" y="3616241"/>
+            <a:off x="2287274" y="3463840"/>
             <a:ext cx="2164718" cy="1797218"/>
           </a:xfrm>
           <a:prstGeom prst="rect">
@@ -3444,7 +3444,7 @@
         </p:nvSpPr>
         <p:spPr>
           <a:xfrm>
-            <a:off x="4762871" y="5543054"/>
+            <a:off x="4547503" y="5390653"/>
             <a:ext cx="2164718" cy="1797218"/>
           </a:xfrm>
           <a:prstGeom prst="rect">
@@ -3498,7 +3498,7 @@
         </p:nvSpPr>
         <p:spPr>
           <a:xfrm>
-            <a:off x="4762871" y="3616241"/>
+            <a:off x="4547503" y="3463840"/>
             <a:ext cx="2164718" cy="1797218"/>
           </a:xfrm>
           <a:prstGeom prst="rect">
@@ -3552,7 +3552,7 @@
         </p:nvSpPr>
         <p:spPr>
           <a:xfrm>
-            <a:off x="2497714" y="3631077"/>
+            <a:off x="2282346" y="3478680"/>
             <a:ext cx="631904" cy="615553"/>
           </a:xfrm>
           <a:prstGeom prst="rect">
@@ -3617,7 +3617,7 @@
         </p:nvSpPr>
         <p:spPr>
           <a:xfrm>
-            <a:off x="4762871" y="3626550"/>
+            <a:off x="4547503" y="3474153"/>
             <a:ext cx="631904" cy="615553"/>
           </a:xfrm>
           <a:prstGeom prst="rect">
@@ -3682,7 +3682,7 @@
         </p:nvSpPr>
         <p:spPr>
           <a:xfrm>
-            <a:off x="4762876" y="5537228"/>
+            <a:off x="4547512" y="5384831"/>
             <a:ext cx="880369" cy="800219"/>
           </a:xfrm>
           <a:prstGeom prst="rect">
@@ -3759,7 +3759,7 @@
         </p:nvSpPr>
         <p:spPr>
           <a:xfrm>
-            <a:off x="2497719" y="5537228"/>
+            <a:off x="2282355" y="5384831"/>
             <a:ext cx="880369" cy="615553"/>
           </a:xfrm>
           <a:prstGeom prst="rect">

</xml_diff>